<commit_message>
Upload the final presentation
</commit_message>
<xml_diff>
--- a/Industrial_Network_Security_final.pptx
+++ b/Industrial_Network_Security_final.pptx
@@ -18641,14 +18641,14 @@
         <p:spPr>
           <a:xfrm>
             <a:off x="792480" y="1374395"/>
-            <a:ext cx="2817575" cy="5373266"/>
+            <a:ext cx="2991580" cy="5091137"/>
           </a:xfrm>
           <a:prstGeom prst="rect">
             <a:avLst/>
           </a:prstGeom>
         </p:spPr>
         <p:txBody>
-          <a:bodyPr lIns="0" tIns="0" rIns="0" bIns="0" rtlCol="0" anchor="t">
+          <a:bodyPr wrap="square" lIns="0" tIns="0" rIns="0" bIns="0" rtlCol="0" anchor="t">
             <a:spAutoFit/>
           </a:bodyPr>
           <a:lstStyle/>
@@ -18746,10 +18746,12 @@
             </a:endParaRPr>
           </a:p>
           <a:p>
-            <a:pPr algn="just">
+            <a:pPr marL="285750" indent="-285750" algn="just">
               <a:lnSpc>
                 <a:spcPts val="1835"/>
               </a:lnSpc>
+              <a:buFont typeface="Arial" panose="020B0604020202020204" pitchFamily="34" charset="0"/>
+              <a:buChar char="•"/>
             </a:pPr>
             <a:endParaRPr lang="en-US" sz="1529" b="1" dirty="0">
               <a:solidFill>

</xml_diff>